<commit_message>
Update Module 3 (Threats and Attacks on Endpoints).pptx
</commit_message>
<xml_diff>
--- a/CS-4451/Modules/Hoang-Xuan-Tung/Module 3 (Threats and Attacks on Endpoints).pptx
+++ b/CS-4451/Modules/Hoang-Xuan-Tung/Module 3 (Threats and Attacks on Endpoints).pptx
@@ -294,7 +294,7 @@
           <a:p>
             <a:fld id="{5E8AA413-85C6-40F2-B867-268CAAA7E377}" type="datetimeFigureOut">
               <a:rPr lang="en-US" smtClean="0"/>
-              <a:t>2/25/2023</a:t>
+              <a:t>3/12/2026</a:t>
             </a:fld>
             <a:endParaRPr lang="en-US" dirty="0"/>
           </a:p>
@@ -484,7 +484,7 @@
               <a:pPr>
                 <a:defRPr/>
               </a:pPr>
-              <a:t>2/25/2023</a:t>
+              <a:t>3/12/2026</a:t>
             </a:fld>
             <a:endParaRPr lang="en-US" dirty="0"/>
           </a:p>
@@ -9508,7 +9508,7 @@
               </a14:hiddenLine>
             </a:ext>
             <a:ext uri="{FAA26D3D-D897-4be2-8F04-BA451C77F1D7}">
-              <ma14:placeholderFlag xmlns:ma14="http://schemas.microsoft.com/office/mac/drawingml/2011/main" xmlns="" val="1"/>
+              <ma14:placeholderFlag xmlns="" xmlns:ma14="http://schemas.microsoft.com/office/mac/drawingml/2011/main" val="1"/>
             </a:ext>
           </a:extLst>
         </p:spPr>
@@ -9570,7 +9570,7 @@
               </a14:hiddenLine>
             </a:ext>
             <a:ext uri="{FAA26D3D-D897-4be2-8F04-BA451C77F1D7}">
-              <ma14:placeholderFlag xmlns:ma14="http://schemas.microsoft.com/office/mac/drawingml/2011/main" xmlns="" val="1"/>
+              <ma14:placeholderFlag xmlns="" xmlns:ma14="http://schemas.microsoft.com/office/mac/drawingml/2011/main" val="1"/>
             </a:ext>
           </a:extLst>
         </p:spPr>
@@ -16424,15 +16424,6 @@
 </file>
 
 <file path=customXml/item1.xml><?xml version="1.0" encoding="utf-8"?>
-<?mso-contentType ?>
-<FormTemplates xmlns="http://schemas.microsoft.com/sharepoint/v3/contenttype/forms">
-  <Display>DocumentLibraryForm</Display>
-  <Edit>DocumentLibraryForm</Edit>
-  <New>DocumentLibraryForm</New>
-</FormTemplates>
-</file>
-
-<file path=customXml/item2.xml><?xml version="1.0" encoding="utf-8"?>
 <p:properties xmlns:p="http://schemas.microsoft.com/office/2006/metadata/properties" xmlns:xsi="http://www.w3.org/2001/XMLSchema-instance" xmlns:pc="http://schemas.microsoft.com/office/infopath/2007/PartnerControls">
   <documentManagement>
     <SharedWithUsers xmlns="48fa25a7-52b6-4e1f-81c8-80356bf0725f">
@@ -16447,7 +16438,7 @@
 </p:properties>
 </file>
 
-<file path=customXml/item3.xml><?xml version="1.0" encoding="utf-8"?>
+<file path=customXml/item2.xml><?xml version="1.0" encoding="utf-8"?>
 <ct:contentTypeSchema xmlns:ct="http://schemas.microsoft.com/office/2006/metadata/contentType" xmlns:ma="http://schemas.microsoft.com/office/2006/metadata/properties/metaAttributes" ct:_="" ma:_="" ma:contentTypeName="Document" ma:contentTypeID="0x0101003689A9510EA35640BFF9AA65172B1243" ma:contentTypeVersion="10" ma:contentTypeDescription="Create a new document." ma:contentTypeScope="" ma:versionID="320cf9d96ba60ad326f31ca465b90014">
   <xsd:schema xmlns:xsd="http://www.w3.org/2001/XMLSchema" xmlns:xs="http://www.w3.org/2001/XMLSchema" xmlns:p="http://schemas.microsoft.com/office/2006/metadata/properties" xmlns:ns2="0f302c04-584d-4df5-8948-8b6dd1f3c1a5" xmlns:ns3="48fa25a7-52b6-4e1f-81c8-80356bf0725f" targetNamespace="http://schemas.microsoft.com/office/2006/metadata/properties" ma:root="true" ma:fieldsID="b2b56c629f8f824a699d99d0a50051e2" ns2:_="" ns3:_="">
     <xsd:import namespace="0f302c04-584d-4df5-8948-8b6dd1f3c1a5"/>
@@ -16643,32 +16634,33 @@
 </ct:contentTypeSchema>
 </file>
 
+<file path=customXml/item3.xml><?xml version="1.0" encoding="utf-8"?>
+<?mso-contentType ?>
+<FormTemplates xmlns="http://schemas.microsoft.com/sharepoint/v3/contenttype/forms">
+  <Display>DocumentLibraryForm</Display>
+  <Edit>DocumentLibraryForm</Edit>
+  <New>DocumentLibraryForm</New>
+</FormTemplates>
+</file>
+
 <file path=customXml/itemProps1.xml><?xml version="1.0" encoding="utf-8"?>
-<ds:datastoreItem xmlns:ds="http://schemas.openxmlformats.org/officeDocument/2006/customXml" ds:itemID="{E32CFAA7-E308-4DCB-89CD-C84C20E90241}">
+<ds:datastoreItem xmlns:ds="http://schemas.openxmlformats.org/officeDocument/2006/customXml" ds:itemID="{BA9BA192-EF86-48DF-982C-2C526A268392}">
   <ds:schemaRefs>
-    <ds:schemaRef ds:uri="http://schemas.microsoft.com/sharepoint/v3/contenttype/forms"/>
+    <ds:schemaRef ds:uri="http://www.w3.org/XML/1998/namespace"/>
+    <ds:schemaRef ds:uri="http://schemas.microsoft.com/office/2006/documentManagement/types"/>
+    <ds:schemaRef ds:uri="http://purl.org/dc/dcmitype/"/>
+    <ds:schemaRef ds:uri="http://schemas.microsoft.com/office/2006/metadata/properties"/>
+    <ds:schemaRef ds:uri="http://purl.org/dc/terms/"/>
+    <ds:schemaRef ds:uri="0f302c04-584d-4df5-8948-8b6dd1f3c1a5"/>
+    <ds:schemaRef ds:uri="http://purl.org/dc/elements/1.1/"/>
+    <ds:schemaRef ds:uri="http://schemas.openxmlformats.org/package/2006/metadata/core-properties"/>
+    <ds:schemaRef ds:uri="http://schemas.microsoft.com/office/infopath/2007/PartnerControls"/>
+    <ds:schemaRef ds:uri="48fa25a7-52b6-4e1f-81c8-80356bf0725f"/>
   </ds:schemaRefs>
 </ds:datastoreItem>
 </file>
 
 <file path=customXml/itemProps2.xml><?xml version="1.0" encoding="utf-8"?>
-<ds:datastoreItem xmlns:ds="http://schemas.openxmlformats.org/officeDocument/2006/customXml" ds:itemID="{BA9BA192-EF86-48DF-982C-2C526A268392}">
-  <ds:schemaRefs>
-    <ds:schemaRef ds:uri="http://purl.org/dc/dcmitype/"/>
-    <ds:schemaRef ds:uri="http://purl.org/dc/terms/"/>
-    <ds:schemaRef ds:uri="http://schemas.microsoft.com/office/2006/metadata/properties"/>
-    <ds:schemaRef ds:uri="http://schemas.openxmlformats.org/package/2006/metadata/core-properties"/>
-    <ds:schemaRef ds:uri="http://schemas.microsoft.com/office/2006/documentManagement/types"/>
-    <ds:schemaRef ds:uri="http://schemas.microsoft.com/office/infopath/2007/PartnerControls"/>
-    <ds:schemaRef ds:uri="http://www.w3.org/XML/1998/namespace"/>
-    <ds:schemaRef ds:uri="http://purl.org/dc/elements/1.1/"/>
-    <ds:schemaRef ds:uri="48fa25a7-52b6-4e1f-81c8-80356bf0725f"/>
-    <ds:schemaRef ds:uri="0f302c04-584d-4df5-8948-8b6dd1f3c1a5"/>
-  </ds:schemaRefs>
-</ds:datastoreItem>
-</file>
-
-<file path=customXml/itemProps3.xml><?xml version="1.0" encoding="utf-8"?>
 <ds:datastoreItem xmlns:ds="http://schemas.openxmlformats.org/officeDocument/2006/customXml" ds:itemID="{385D83D5-733A-4FD2-B124-BEA55F840D9D}">
   <ds:schemaRefs>
     <ds:schemaRef ds:uri="http://schemas.microsoft.com/office/2006/metadata/contentType"/>
@@ -16685,4 +16677,12 @@
     <ds:schemaRef ds:uri="http://schemas.microsoft.com/internal/obd"/>
   </ds:schemaRefs>
 </ds:datastoreItem>
+</file>
+
+<file path=customXml/itemProps3.xml><?xml version="1.0" encoding="utf-8"?>
+<ds:datastoreItem xmlns:ds="http://schemas.openxmlformats.org/officeDocument/2006/customXml" ds:itemID="{E32CFAA7-E308-4DCB-89CD-C84C20E90241}">
+  <ds:schemaRefs>
+    <ds:schemaRef ds:uri="http://schemas.microsoft.com/sharepoint/v3/contenttype/forms"/>
+  </ds:schemaRefs>
+</ds:datastoreItem>
 </file>
</xml_diff>